<commit_message>
Base pitch v2 on VZP data; fix wording of the invited cohort
Slide 1 now starts from the 2024 VZP invitations: 256,466 invited,
19 % came, 207,201 did not. The theoretical ceiling is "all of them
came": about 1,100 cancers found earlier, 135 deaths averted, 790 QALY
and 100 M Kc net a year. The result slide gives 5-10 % of that ceiling.
dopad.py computes both the VZP and the national ceiling; the national
figures (CSU, UZIS, NOR) remain only in the speaker notes as context.

The invited women are described as "hlavně ty, které na screening
dlouho nepřišly, a ženy zvané poprvé" instead of the misleading "mimo
doporučený interval". Office lock files (~$*) are ignored.

Co-Authored-By: Claude Opus 5.5 <noreply@anthropic.com>
</commit_message>
<xml_diff>
--- a/docs/vzp_pitch/pitch_v2.pptx
+++ b/docs/vzp_pitch/pitch_v2.pptx
@@ -235,7 +235,7 @@
                   <a:srgbClr val="4A4458"/>
                 </a:solidFill>
               </a:rPr>
-              <a:t>Stadium při diagnóze, ≈ 2 300 nádorů ročně (%)</a:t>
+              <a:t>Stadium při diagnóze, ≈ 1 100 nádorů ročně (%)</a:t>
             </a:r>
           </a:p>
         </c:rich>
@@ -780,7 +780,7 @@
           <a:lstStyle/>
           <a:p>
             <a:r>
-              <a:t>40 s. V Česku je 2,19 milionu žen ve věku 45 až 74 let. Za poslední dva roky přišlo na screening 61 procent, zhruba 850 tisíc žen ne. U nich se ročně najde asi 2 300 karcinomů prsu a jen necelá třetina v prvním stadiu; ve screeningu jsou to tři čtvrtiny. Kdyby přišly všechny, šlo by ročně o 2 300 nádorů zachycených dřív, asi 275 odvrácených úmrtí, 1 600 let života ve zdraví a 210 milionů korun čisté úspory. Je to teoretický strop; data VZP pokrývají jeho část, 207 tisíc pozvaných žen, které v roce 2024 nepřišly. (Výpočet v docs/vzp_pitch/dopad.py. Kontrola: incidence NOR 45–74 × podíl bez screeningu = 2 262 nádorů. Čistá úspora platí při ceně léčby IV. stadia 3 mil. Kč, pod 1,9 mil. Kč vychází nula; náklady modelu zahrnují příspěvek 1 000 Kč na vyšetření, ověřit s týmem. Robustní metrika: 0,26 mil. Kč za QALY.)</a:t>
+              <a:t>40 s. V roce 2024 VZP adresně pozvala 256 tisíc žen, které na screening dlouho nepřišly nebo byly zvané poprvé, a 207 tisíc z nich do roka nepřišlo. Kdyby přišly, screening by u nich ročně našel asi 1 100 karcinomů prsu dřív. Bez screeningu je v prvním stadiu necelá třetina nádorů, ve screeningu tři čtvrtiny. Kdyby přišly všechny, šlo by ročně o asi 135 odvrácených úmrtí, 790 let života ve zdraví a 100 milionů korun čisté úspory. To je teoretický strop. (Výpočet v docs/vzp_pitch/dopad.py, jedno vyšetření na ženu ročně. Kontext, nečíst: celostátně je 2,19 mil. žen 45–74, za dva roky přišlo 61 %, tedy nejméně 850 tisíc žen bez screeningu a asi 2 300 nádorů ročně (ČSÚ, ÚZIS, NOR). Čistá úspora platí při ceně léčby IV. stadia 3 mil. Kč, pod 1,9 mil. Kč vychází nula; náklady modelu zahrnují příspěvek 1 000 Kč na vyšetření, ověřit s týmem. Robustní metrika: 0,26 mil. Kč za QALY.)</a:t>
             </a:r>
           </a:p>
         </p:txBody>
@@ -2531,7 +2531,7 @@
           <a:lstStyle/>
           <a:p>
             <a:r>
-              <a:t>U 850 tisíc žen bez screeningu se nádory prsu najdou pozdě</a:t>
+              <a:t>U 207 tisíc pozvaných žen, které nepřišly, se nádory najdou pozdě</a:t>
             </a:r>
           </a:p>
         </p:txBody>
@@ -2569,7 +2569,7 @@
                   <a:srgbClr val="4A4458"/>
                 </a:solidFill>
               </a:rPr>
-              <a:t>Za roky 2023–2024 přišlo na screeningovou mamografii 61 % z 2,19 mil. žen ve věku 45–74 let. U zbylých se ročně zjistí asi 2 300 karcinomů prsu, většinou později, než by je našel screening.</a:t>
+              <a:t>V roce 2024 VZP adresně pozvala 256 466 žen, hlavně ty, které na screening dlouho nepřišly, a ženy zvané poprvé. Do 12 měsíců jich přišlo 19 %. Kdyby přišly všechny, screening by ročně našel asi 1 100 karcinomů prsu dřív.</a:t>
             </a:r>
           </a:p>
         </p:txBody>
@@ -2577,45 +2577,6 @@
       <p:sp>
         <p:nvSpPr>
           <p:cNvPr id="5" name="Rounded Rectangle 4"/>
-          <p:cNvSpPr/>
-          <p:nvPr/>
-        </p:nvSpPr>
-        <p:spPr>
-          <a:xfrm>
-            <a:off x="8403336" y="457200"/>
-            <a:ext cx="1005840" cy="246888"/>
-          </a:xfrm>
-          <a:prstGeom prst="roundRect">
-            <a:avLst>
-              <a:gd name="adj" fmla="val 50000"/>
-            </a:avLst>
-          </a:prstGeom>
-          <a:solidFill>
-            <a:srgbClr val="7A78C3"/>
-          </a:solidFill>
-          <a:ln>
-            <a:noFill/>
-          </a:ln>
-        </p:spPr>
-        <p:txBody>
-          <a:bodyPr rtlCol="0" anchor="ctr" lIns="0" rIns="0" tIns="0" bIns="0"/>
-          <a:lstStyle/>
-          <a:p>
-            <a:pPr algn="ctr"/>
-            <a:r>
-              <a:rPr sz="900" b="1">
-                <a:solidFill>
-                  <a:srgbClr val="FFFFFF"/>
-                </a:solidFill>
-              </a:rPr>
-              <a:t>ÚZIS a ČSÚ</a:t>
-            </a:r>
-          </a:p>
-        </p:txBody>
-      </p:sp>
-      <p:sp>
-        <p:nvSpPr>
-          <p:cNvPr id="6" name="Rounded Rectangle 5"/>
           <p:cNvSpPr/>
           <p:nvPr/>
         </p:nvSpPr>
@@ -2654,7 +2615,7 @@
       </p:sp>
       <p:sp>
         <p:nvSpPr>
-          <p:cNvPr id="7" name="Rounded Rectangle 6"/>
+          <p:cNvPr id="6" name="Rounded Rectangle 5"/>
           <p:cNvSpPr/>
           <p:nvPr/>
         </p:nvSpPr>
@@ -2693,7 +2654,7 @@
       </p:sp>
       <p:sp>
         <p:nvSpPr>
-          <p:cNvPr id="8" name="Rounded Rectangle 7"/>
+          <p:cNvPr id="7" name="Rounded Rectangle 6"/>
           <p:cNvSpPr/>
           <p:nvPr/>
         </p:nvSpPr>
@@ -2726,7 +2687,7 @@
       </p:sp>
       <p:sp>
         <p:nvSpPr>
-          <p:cNvPr id="9" name="TextBox 8"/>
+          <p:cNvPr id="8" name="TextBox 7"/>
           <p:cNvSpPr txBox="1"/>
           <p:nvPr/>
         </p:nvSpPr>
@@ -2757,14 +2718,14 @@
                   <a:srgbClr val="003B7A"/>
                 </a:solidFill>
               </a:rPr>
-              <a:t>2,19 mil.</a:t>
-            </a:r>
-          </a:p>
-        </p:txBody>
-      </p:sp>
-      <p:sp>
-        <p:nvSpPr>
-          <p:cNvPr id="10" name="TextBox 9"/>
+              <a:t>256 466</a:t>
+            </a:r>
+          </a:p>
+        </p:txBody>
+      </p:sp>
+      <p:sp>
+        <p:nvSpPr>
+          <p:cNvPr id="9" name="TextBox 8"/>
           <p:cNvSpPr txBox="1"/>
           <p:nvPr/>
         </p:nvSpPr>
@@ -2795,14 +2756,14 @@
                   <a:srgbClr val="4A4458"/>
                 </a:solidFill>
               </a:rPr>
-              <a:t>žen ve věku 45–74 let (ČSÚ 2024)</a:t>
-            </a:r>
-          </a:p>
-        </p:txBody>
-      </p:sp>
-      <p:sp>
-        <p:nvSpPr>
-          <p:cNvPr id="11" name="Right Arrow 10"/>
+              <a:t>žen VZP v roce 2024 adresně pozvala (nechodí na screening nebo zvané poprvé)</a:t>
+            </a:r>
+          </a:p>
+        </p:txBody>
+      </p:sp>
+      <p:sp>
+        <p:nvSpPr>
+          <p:cNvPr id="10" name="Right Arrow 9"/>
           <p:cNvSpPr/>
           <p:nvPr/>
         </p:nvSpPr>
@@ -2831,7 +2792,7 @@
       </p:sp>
       <p:sp>
         <p:nvSpPr>
-          <p:cNvPr id="12" name="Rounded Rectangle 11"/>
+          <p:cNvPr id="11" name="Rounded Rectangle 10"/>
           <p:cNvSpPr/>
           <p:nvPr/>
         </p:nvSpPr>
@@ -2864,7 +2825,7 @@
       </p:sp>
       <p:sp>
         <p:nvSpPr>
-          <p:cNvPr id="13" name="TextBox 12"/>
+          <p:cNvPr id="12" name="TextBox 11"/>
           <p:cNvSpPr txBox="1"/>
           <p:nvPr/>
         </p:nvSpPr>
@@ -2895,14 +2856,14 @@
                   <a:srgbClr val="3D7CC9"/>
                 </a:solidFill>
               </a:rPr>
-              <a:t>61 %</a:t>
-            </a:r>
-          </a:p>
-        </p:txBody>
-      </p:sp>
-      <p:sp>
-        <p:nvSpPr>
-          <p:cNvPr id="14" name="TextBox 13"/>
+              <a:t>19 %</a:t>
+            </a:r>
+          </a:p>
+        </p:txBody>
+      </p:sp>
+      <p:sp>
+        <p:nvSpPr>
+          <p:cNvPr id="13" name="TextBox 12"/>
           <p:cNvSpPr txBox="1"/>
           <p:nvPr/>
         </p:nvSpPr>
@@ -2933,14 +2894,14 @@
                   <a:srgbClr val="4A4458"/>
                 </a:solidFill>
               </a:rPr>
-              <a:t>přišlo na screening za 2 roky (ÚZIS 2023–24)</a:t>
-            </a:r>
-          </a:p>
-        </p:txBody>
-      </p:sp>
-      <p:sp>
-        <p:nvSpPr>
-          <p:cNvPr id="15" name="Right Arrow 14"/>
+              <a:t>přišlo do 12 měsíců</a:t>
+            </a:r>
+          </a:p>
+        </p:txBody>
+      </p:sp>
+      <p:sp>
+        <p:nvSpPr>
+          <p:cNvPr id="14" name="Right Arrow 13"/>
           <p:cNvSpPr/>
           <p:nvPr/>
         </p:nvSpPr>
@@ -2969,7 +2930,7 @@
       </p:sp>
       <p:sp>
         <p:nvSpPr>
-          <p:cNvPr id="16" name="Rounded Rectangle 15"/>
+          <p:cNvPr id="15" name="Rounded Rectangle 14"/>
           <p:cNvSpPr/>
           <p:nvPr/>
         </p:nvSpPr>
@@ -3002,7 +2963,7 @@
       </p:sp>
       <p:sp>
         <p:nvSpPr>
-          <p:cNvPr id="17" name="TextBox 16"/>
+          <p:cNvPr id="16" name="TextBox 15"/>
           <p:cNvSpPr txBox="1"/>
           <p:nvPr/>
         </p:nvSpPr>
@@ -3033,14 +2994,14 @@
                   <a:srgbClr val="D27869"/>
                 </a:solidFill>
               </a:rPr>
-              <a:t>≈ 850 tis.</a:t>
-            </a:r>
-          </a:p>
-        </p:txBody>
-      </p:sp>
-      <p:sp>
-        <p:nvSpPr>
-          <p:cNvPr id="18" name="TextBox 17"/>
+              <a:t>207 201</a:t>
+            </a:r>
+          </a:p>
+        </p:txBody>
+      </p:sp>
+      <p:sp>
+        <p:nvSpPr>
+          <p:cNvPr id="17" name="TextBox 16"/>
           <p:cNvSpPr txBox="1"/>
           <p:nvPr/>
         </p:nvSpPr>
@@ -3071,14 +3032,14 @@
                   <a:srgbClr val="4A4458"/>
                 </a:solidFill>
               </a:rPr>
-              <a:t>žen bez mamografie; z nich 207 tis. pozvaných VZP v roce 2024 nepřišlo</a:t>
+              <a:t>žen nepřišlo</a:t>
             </a:r>
           </a:p>
         </p:txBody>
       </p:sp>
       <p:graphicFrame>
         <p:nvGraphicFramePr>
-          <p:cNvPr id="19" name="Chart 18"/>
+          <p:cNvPr id="18" name="Chart 17"/>
           <p:cNvGraphicFramePr>
             <a:graphicFrameLocks noGrp="1"/>
           </p:cNvGraphicFramePr>
@@ -3096,7 +3057,7 @@
       </p:graphicFrame>
       <p:sp>
         <p:nvSpPr>
-          <p:cNvPr id="20" name="TextBox 19"/>
+          <p:cNvPr id="19" name="TextBox 18"/>
           <p:cNvSpPr txBox="1"/>
           <p:nvPr/>
         </p:nvSpPr>
@@ -3134,7 +3095,7 @@
       </p:sp>
       <p:sp>
         <p:nvSpPr>
-          <p:cNvPr id="21" name="Rounded Rectangle 20"/>
+          <p:cNvPr id="20" name="Rounded Rectangle 19"/>
           <p:cNvSpPr/>
           <p:nvPr/>
         </p:nvSpPr>
@@ -3167,7 +3128,7 @@
       </p:sp>
       <p:sp>
         <p:nvSpPr>
-          <p:cNvPr id="22" name="TextBox 21"/>
+          <p:cNvPr id="21" name="TextBox 20"/>
           <p:cNvSpPr txBox="1"/>
           <p:nvPr/>
         </p:nvSpPr>
@@ -3220,7 +3181,7 @@
       </p:sp>
       <p:sp>
         <p:nvSpPr>
-          <p:cNvPr id="23" name="TextBox 22"/>
+          <p:cNvPr id="22" name="TextBox 21"/>
           <p:cNvSpPr txBox="1"/>
           <p:nvPr/>
         </p:nvSpPr>
@@ -3251,14 +3212,14 @@
                   <a:srgbClr val="D27869"/>
                 </a:solidFill>
               </a:rPr>
-              <a:t>≈ 2 300</a:t>
-            </a:r>
-          </a:p>
-        </p:txBody>
-      </p:sp>
-      <p:sp>
-        <p:nvSpPr>
-          <p:cNvPr id="24" name="TextBox 23"/>
+              <a:t>≈ 1 100</a:t>
+            </a:r>
+          </a:p>
+        </p:txBody>
+      </p:sp>
+      <p:sp>
+        <p:nvSpPr>
+          <p:cNvPr id="23" name="TextBox 22"/>
           <p:cNvSpPr txBox="1"/>
           <p:nvPr/>
         </p:nvSpPr>
@@ -3296,7 +3257,7 @@
       </p:sp>
       <p:sp>
         <p:nvSpPr>
-          <p:cNvPr id="25" name="TextBox 24"/>
+          <p:cNvPr id="24" name="TextBox 23"/>
           <p:cNvSpPr txBox="1"/>
           <p:nvPr/>
         </p:nvSpPr>
@@ -3327,14 +3288,14 @@
                   <a:srgbClr val="D27869"/>
                 </a:solidFill>
               </a:rPr>
-              <a:t>≈ 275</a:t>
-            </a:r>
-          </a:p>
-        </p:txBody>
-      </p:sp>
-      <p:sp>
-        <p:nvSpPr>
-          <p:cNvPr id="26" name="TextBox 25"/>
+              <a:t>≈ 135</a:t>
+            </a:r>
+          </a:p>
+        </p:txBody>
+      </p:sp>
+      <p:sp>
+        <p:nvSpPr>
+          <p:cNvPr id="25" name="TextBox 24"/>
           <p:cNvSpPr txBox="1"/>
           <p:nvPr/>
         </p:nvSpPr>
@@ -3372,7 +3333,7 @@
       </p:sp>
       <p:sp>
         <p:nvSpPr>
-          <p:cNvPr id="27" name="TextBox 26"/>
+          <p:cNvPr id="26" name="TextBox 25"/>
           <p:cNvSpPr txBox="1"/>
           <p:nvPr/>
         </p:nvSpPr>
@@ -3403,14 +3364,14 @@
                   <a:srgbClr val="D27869"/>
                 </a:solidFill>
               </a:rPr>
-              <a:t>≈ 1 600</a:t>
-            </a:r>
-          </a:p>
-        </p:txBody>
-      </p:sp>
-      <p:sp>
-        <p:nvSpPr>
-          <p:cNvPr id="28" name="TextBox 27"/>
+              <a:t>≈ 790</a:t>
+            </a:r>
+          </a:p>
+        </p:txBody>
+      </p:sp>
+      <p:sp>
+        <p:nvSpPr>
+          <p:cNvPr id="27" name="TextBox 26"/>
           <p:cNvSpPr txBox="1"/>
           <p:nvPr/>
         </p:nvSpPr>
@@ -3448,7 +3409,7 @@
       </p:sp>
       <p:sp>
         <p:nvSpPr>
-          <p:cNvPr id="29" name="TextBox 28"/>
+          <p:cNvPr id="28" name="TextBox 27"/>
           <p:cNvSpPr txBox="1"/>
           <p:nvPr/>
         </p:nvSpPr>
@@ -3479,14 +3440,14 @@
                   <a:srgbClr val="D27869"/>
                 </a:solidFill>
               </a:rPr>
-              <a:t>≈ 210 mil. Kč</a:t>
-            </a:r>
-          </a:p>
-        </p:txBody>
-      </p:sp>
-      <p:sp>
-        <p:nvSpPr>
-          <p:cNvPr id="30" name="TextBox 29"/>
+              <a:t>≈ 100 mil. Kč</a:t>
+            </a:r>
+          </a:p>
+        </p:txBody>
+      </p:sp>
+      <p:sp>
+        <p:nvSpPr>
+          <p:cNvPr id="29" name="TextBox 28"/>
           <p:cNvSpPr txBox="1"/>
           <p:nvPr/>
         </p:nvSpPr>
@@ -3524,7 +3485,7 @@
       </p:sp>
       <p:sp>
         <p:nvSpPr>
-          <p:cNvPr id="31" name="TextBox 30"/>
+          <p:cNvPr id="30" name="TextBox 29"/>
           <p:cNvSpPr txBox="1"/>
           <p:nvPr/>
         </p:nvSpPr>
@@ -3555,7 +3516,7 @@
                   <a:srgbClr val="8A8597"/>
                 </a:solidFill>
               </a:rPr>
-              <a:t>Zdroj: ČSÚ 2024, ÚZIS PPS 2023–24, NOR 2024; stadia: audit screeningu 2023, ÚZIS 2022; finanční model týmu (docs/vzp_pitch/dopad.py)</a:t>
+              <a:t>Zdroj: data VZP pro Rakathon 2026, pozvánky 2024; stadia: audit screeningu 2023, ÚZIS 2022; finanční model týmu (docs/vzp_pitch/dopad.py)</a:t>
             </a:r>
           </a:p>
         </p:txBody>
@@ -7902,7 +7863,7 @@
                   <a:srgbClr val="4A4458"/>
                 </a:solidFill>
               </a:rPr>
-              <a:t>2–5 % teoretického stropu</a:t>
+              <a:t>5–10 % teoretického stropu</a:t>
             </a:r>
             <a:r>
               <a:rPr sz="1050" b="0">
@@ -7910,7 +7871,7 @@
                   <a:srgbClr val="4A4458"/>
                 </a:solidFill>
               </a:rPr>
-              <a:t>, jen z cílených kanálů v datech VZP. Plošná digitální kaskáda podle finančního modelu přinese 156 mil. Kč čistě za 2027–2031.</a:t>
+              <a:t>, jen z cílených kanálů v segmentech B–E. Plošná digitální kaskáda podle finančního modelu přinese 156 mil. Kč čistě za 2027–2031.</a:t>
             </a:r>
           </a:p>
           <a:p>

</xml_diff>